<commit_message>
docs: atualiza apresentações v2 (HTML+PPTX) para a rodada vigente
- Apresentacao_QuatroNorte_v2.html e _v2.pptx atualizados in-place (sem gerador
  reprodutível): R² 0,085 / RMSE 0,243 / MAE 0,131; custo CAD 77,0 mi nominal /
  82,3 mi real; 351.956 observações; 223.590 OS (fato_wo_ml).
- unit_subtype incluída como a categórica mais forte (η = 0,128) no gráfico de
  associação e nas conclusões (H5); região reescalada.
- GUIA e revisao_pos_base_nova: v2 marcadas como atualizadas/vigentes.

Co-Authored-By: Claude Fable 5 <noreply@anthropic.com>
</commit_message>
<xml_diff>
--- a/docs/entregas/Apresentacao_QuatroNorte_v2.pptx
+++ b/docs/entregas/Apresentacao_QuatroNorte_v2.pptx
@@ -8415,7 +8415,7 @@
                 <a:ea typeface="Arial" pitchFamily="34" charset="-122"/>
                 <a:cs typeface="Arial" pitchFamily="34" charset="-120"/>
               </a:rPr>
-              <a:t>CAD 79,0 mi</a:t>
+              <a:t>CAD 77,0 mi</a:t>
             </a:r>
             <a:endParaRPr lang="en-US" sz="5250" dirty="0"/>
           </a:p>
@@ -8456,7 +8456,7 @@
                 <a:ea typeface="Arial" pitchFamily="34" charset="-122"/>
                 <a:cs typeface="Arial" pitchFamily="34" charset="-120"/>
               </a:rPr>
-              <a:t>custo interno nominal 2020–2025 (CAD 84,3 mi a valores de dez/2025)</a:t>
+              <a:t>custo interno nominal 2020–2025 (CAD 82,3 mi a valores de dez/2025)</a:t>
             </a:r>
             <a:endParaRPr lang="en-US" sz="1725" dirty="0"/>
           </a:p>
@@ -8524,7 +8524,7 @@
                 <a:ea typeface="Arial" pitchFamily="34" charset="-122"/>
                 <a:cs typeface="Arial" pitchFamily="34" charset="-120"/>
               </a:rPr>
-              <a:t>238.818</a:t>
+              <a:t>223.590</a:t>
             </a:r>
             <a:endParaRPr lang="en-US" sz="3900" dirty="0"/>
           </a:p>
@@ -10762,7 +10762,7 @@
                 <a:ea typeface="Arial" pitchFamily="34" charset="-122"/>
                 <a:cs typeface="Arial" pitchFamily="34" charset="-120"/>
               </a:rPr>
-              <a:t>352.038</a:t>
+              <a:t>351.956</a:t>
             </a:r>
             <a:endParaRPr lang="en-US" sz="3750" dirty="0"/>
           </a:p>
@@ -13894,7 +13894,7 @@
                 <a:ea typeface="Arial" pitchFamily="34" charset="-122"/>
                 <a:cs typeface="Arial" pitchFamily="34" charset="-120"/>
               </a:rPr>
-              <a:t>238.818</a:t>
+              <a:t>223.590</a:t>
             </a:r>
             <a:endParaRPr lang="en-US" sz="4350" dirty="0"/>
           </a:p>
@@ -18275,7 +18275,7 @@
                 <a:ea typeface="Courier New" pitchFamily="34" charset="-122"/>
                 <a:cs typeface="Courier New" pitchFamily="34" charset="-120"/>
               </a:rPr>
-              <a:t>352.038 observações carreta × mês · protocolo variável a variável</a:t>
+              <a:t>351.956 observações carreta × mês · protocolo variável a variável</a:t>
             </a:r>
             <a:endParaRPr lang="en-US" sz="2175" dirty="0"/>
           </a:p>
@@ -19372,7 +19372,7 @@
                 <a:ea typeface="Courier New" pitchFamily="34" charset="-122"/>
                 <a:cs typeface="Courier New" pitchFamily="34" charset="-120"/>
               </a:rPr>
-              <a:t>352.038</a:t>
+              <a:t>351.956</a:t>
             </a:r>
             <a:endParaRPr lang="en-US" sz="1575" dirty="0"/>
           </a:p>
@@ -23894,7 +23894,7 @@
                 <a:ea typeface="Courier New" pitchFamily="34" charset="-122"/>
                 <a:cs typeface="Courier New" pitchFamily="34" charset="-120"/>
               </a:rPr>
-              <a:t>352.038</a:t>
+              <a:t>351.956</a:t>
             </a:r>
             <a:endParaRPr lang="en-US" sz="1575" dirty="0"/>
           </a:p>
@@ -30261,7 +30261,7 @@
                 <a:ea typeface="Courier New" pitchFamily="34" charset="-122"/>
                 <a:cs typeface="Courier New" pitchFamily="34" charset="-120"/>
               </a:rPr>
-              <a:t>η = 0,084 · a categórica mais forte · H5</a:t>
+              <a:t>η = 0,084 · 2ª mais forte (após unit_subtype) · H5</a:t>
             </a:r>
             <a:endParaRPr lang="en-US" sz="1650" dirty="0"/>
           </a:p>
@@ -30964,7 +30964,7 @@
                 <a:ea typeface="Arial" pitchFamily="34" charset="-122"/>
                 <a:cs typeface="Arial" pitchFamily="34" charset="-120"/>
               </a:rPr>
-              <a:t>Clima, estradas e custo de oficina local mudam o custo por km — a região é a categórica mais forte e dá suporte parcial à H5 pelo lado operacional.</a:t>
+              <a:t>Clima, estradas e custo de oficina local mudam o custo por km — a região é uma das mais fortes (atrás de unit_subtype, η = 0,128) e dá suporte parcial à H5.</a:t>
             </a:r>
             <a:endParaRPr lang="en-US" sz="1725" dirty="0"/>
           </a:p>
@@ -36447,7 +36447,7 @@
                 <a:ea typeface="Courier New" pitchFamily="34" charset="-122"/>
                 <a:cs typeface="Courier New" pitchFamily="34" charset="-120"/>
               </a:rPr>
-              <a:t>0,086</a:t>
+              <a:t>0,085</a:t>
             </a:r>
             <a:endParaRPr lang="en-US" sz="1650" dirty="0"/>
           </a:p>
@@ -36488,7 +36488,7 @@
                 <a:ea typeface="Courier New" pitchFamily="34" charset="-122"/>
                 <a:cs typeface="Courier New" pitchFamily="34" charset="-120"/>
               </a:rPr>
-              <a:t>0,242</a:t>
+              <a:t>0,243</a:t>
             </a:r>
             <a:endParaRPr lang="en-US" sz="1650" dirty="0"/>
           </a:p>
@@ -36529,7 +36529,7 @@
                 <a:ea typeface="Courier New" pitchFamily="34" charset="-122"/>
                 <a:cs typeface="Courier New" pitchFamily="34" charset="-120"/>
               </a:rPr>
-              <a:t>0,132</a:t>
+              <a:t>0,131</a:t>
             </a:r>
             <a:endParaRPr lang="en-US" sz="1650" dirty="0"/>
           </a:p>
@@ -36645,7 +36645,7 @@
                 <a:ea typeface="Courier New" pitchFamily="34" charset="-122"/>
                 <a:cs typeface="Courier New" pitchFamily="34" charset="-120"/>
               </a:rPr>
-              <a:t>0,077</a:t>
+              <a:t>0,079</a:t>
             </a:r>
             <a:endParaRPr lang="en-US" sz="1575" dirty="0"/>
           </a:p>
@@ -36686,7 +36686,7 @@
                 <a:ea typeface="Courier New" pitchFamily="34" charset="-122"/>
                 <a:cs typeface="Courier New" pitchFamily="34" charset="-120"/>
               </a:rPr>
-              <a:t>0,244</a:t>
+              <a:t>0,243</a:t>
             </a:r>
             <a:endParaRPr lang="en-US" sz="1575" dirty="0"/>
           </a:p>
@@ -36727,7 +36727,7 @@
                 <a:ea typeface="Courier New" pitchFamily="34" charset="-122"/>
                 <a:cs typeface="Courier New" pitchFamily="34" charset="-120"/>
               </a:rPr>
-              <a:t>0,133</a:t>
+              <a:t>0,132</a:t>
             </a:r>
             <a:endParaRPr lang="en-US" sz="1575" dirty="0"/>
           </a:p>
@@ -36843,7 +36843,7 @@
                 <a:ea typeface="Courier New" pitchFamily="34" charset="-122"/>
                 <a:cs typeface="Courier New" pitchFamily="34" charset="-120"/>
               </a:rPr>
-              <a:t>0,071</a:t>
+              <a:t>0,072</a:t>
             </a:r>
             <a:endParaRPr lang="en-US" sz="1575" dirty="0"/>
           </a:p>
@@ -36884,7 +36884,7 @@
                 <a:ea typeface="Courier New" pitchFamily="34" charset="-122"/>
                 <a:cs typeface="Courier New" pitchFamily="34" charset="-120"/>
               </a:rPr>
-              <a:t>0,245</a:t>
+              <a:t>0,244</a:t>
             </a:r>
             <a:endParaRPr lang="en-US" sz="1575" dirty="0"/>
           </a:p>
@@ -36925,7 +36925,7 @@
                 <a:ea typeface="Courier New" pitchFamily="34" charset="-122"/>
                 <a:cs typeface="Courier New" pitchFamily="34" charset="-120"/>
               </a:rPr>
-              <a:t>0,145</a:t>
+              <a:t>0,138</a:t>
             </a:r>
             <a:endParaRPr lang="en-US" sz="1575" dirty="0"/>
           </a:p>
@@ -37041,7 +37041,7 @@
                 <a:ea typeface="Courier New" pitchFamily="34" charset="-122"/>
                 <a:cs typeface="Courier New" pitchFamily="34" charset="-120"/>
               </a:rPr>
-              <a:t>0,042</a:t>
+              <a:t>0,055</a:t>
             </a:r>
             <a:endParaRPr lang="en-US" sz="1575" dirty="0"/>
           </a:p>
@@ -37082,7 +37082,7 @@
                 <a:ea typeface="Courier New" pitchFamily="34" charset="-122"/>
                 <a:cs typeface="Courier New" pitchFamily="34" charset="-120"/>
               </a:rPr>
-              <a:t>0,248</a:t>
+              <a:t>0,247</a:t>
             </a:r>
             <a:endParaRPr lang="en-US" sz="1575" dirty="0"/>
           </a:p>
@@ -37123,7 +37123,7 @@
                 <a:ea typeface="Courier New" pitchFamily="34" charset="-122"/>
                 <a:cs typeface="Courier New" pitchFamily="34" charset="-120"/>
               </a:rPr>
-              <a:t>0,133</a:t>
+              <a:t>0,129</a:t>
             </a:r>
             <a:endParaRPr lang="en-US" sz="1575" dirty="0"/>
           </a:p>
@@ -37239,7 +37239,7 @@
                 <a:ea typeface="Courier New" pitchFamily="34" charset="-122"/>
                 <a:cs typeface="Courier New" pitchFamily="34" charset="-120"/>
               </a:rPr>
-              <a:t>0,041</a:t>
+              <a:t>0,044</a:t>
             </a:r>
             <a:endParaRPr lang="en-US" sz="1575" dirty="0"/>
           </a:p>
@@ -37280,7 +37280,7 @@
                 <a:ea typeface="Courier New" pitchFamily="34" charset="-122"/>
                 <a:cs typeface="Courier New" pitchFamily="34" charset="-120"/>
               </a:rPr>
-              <a:t>0,248</a:t>
+              <a:t>0,247</a:t>
             </a:r>
             <a:endParaRPr lang="en-US" sz="1575" dirty="0"/>
           </a:p>
@@ -37321,7 +37321,7 @@
                 <a:ea typeface="Courier New" pitchFamily="34" charset="-122"/>
                 <a:cs typeface="Courier New" pitchFamily="34" charset="-120"/>
               </a:rPr>
-              <a:t>0,137</a:t>
+              <a:t>0,134</a:t>
             </a:r>
             <a:endParaRPr lang="en-US" sz="1575" dirty="0"/>
           </a:p>
@@ -41231,7 +41231,7 @@
                 <a:ea typeface="Arial" pitchFamily="34" charset="-122"/>
                 <a:cs typeface="Arial" pitchFamily="34" charset="-120"/>
               </a:rPr>
-              <a:t>região η = 0,084 · reefer e montadora deslocam; contrato fraco</a:t>
+              <a:t>unit_subtype η = 0,128 (mais forte) · região 0,084 · reefer desloca; contrato fraco</a:t>
             </a:r>
             <a:endParaRPr lang="en-US" sz="1575" dirty="0"/>
           </a:p>

</xml_diff>